<commit_message>
feat: Update presentation file with new content and enhancements
</commit_message>
<xml_diff>
--- a/Presentation1.pptx
+++ b/Presentation1.pptx
@@ -14,6 +14,14 @@
     <p:sldId id="262" r:id="rId8"/>
     <p:sldId id="263" r:id="rId9"/>
     <p:sldId id="264" r:id="rId10"/>
+    <p:sldId id="265" r:id="rId11"/>
+    <p:sldId id="266" r:id="rId12"/>
+    <p:sldId id="267" r:id="rId13"/>
+    <p:sldId id="268" r:id="rId14"/>
+    <p:sldId id="269" r:id="rId15"/>
+    <p:sldId id="270" r:id="rId16"/>
+    <p:sldId id="271" r:id="rId17"/>
+    <p:sldId id="272" r:id="rId18"/>
   </p:sldIdLst>
   <p:sldSz cx="12192000" cy="6858000"/>
   <p:notesSz cx="6858000" cy="9144000"/>
@@ -113,6 +121,140 @@
     </a:lvl9pPr>
   </p:defaultTextStyle>
 </p:presentation>
+</file>
+
+<file path=ppt/changesInfos/changesInfo1.xml><?xml version="1.0" encoding="utf-8"?>
+<pc:chgInfo xmlns:a="http://schemas.openxmlformats.org/drawingml/2006/main" xmlns:r="http://schemas.openxmlformats.org/officeDocument/2006/relationships" xmlns:ac="http://schemas.microsoft.com/office/drawing/2013/main/command" xmlns:pc="http://schemas.microsoft.com/office/powerpoint/2013/main/command">
+  <pc:docChgLst>
+    <pc:chgData name="Rajat Agrawal" userId="bde76780b0933dcb" providerId="LiveId" clId="{860403D2-3B03-4966-B452-B6BB53B3389A}"/>
+    <pc:docChg chg="addSld modSld">
+      <pc:chgData name="Rajat Agrawal" userId="bde76780b0933dcb" providerId="LiveId" clId="{860403D2-3B03-4966-B452-B6BB53B3389A}" dt="2026-09-17T19:44:17.664" v="22" actId="14100"/>
+      <pc:docMkLst>
+        <pc:docMk/>
+      </pc:docMkLst>
+      <pc:sldChg chg="addSp new mod">
+        <pc:chgData name="Rajat Agrawal" userId="bde76780b0933dcb" providerId="LiveId" clId="{860403D2-3B03-4966-B452-B6BB53B3389A}" dt="2026-09-17T18:29:39.339" v="1" actId="22"/>
+        <pc:sldMkLst>
+          <pc:docMk/>
+          <pc:sldMk cId="459814618" sldId="265"/>
+        </pc:sldMkLst>
+        <pc:picChg chg="add">
+          <ac:chgData name="Rajat Agrawal" userId="bde76780b0933dcb" providerId="LiveId" clId="{860403D2-3B03-4966-B452-B6BB53B3389A}" dt="2026-09-17T18:29:39.339" v="1" actId="22"/>
+          <ac:picMkLst>
+            <pc:docMk/>
+            <pc:sldMk cId="459814618" sldId="265"/>
+            <ac:picMk id="3" creationId="{6AB7A7AA-B285-E7DE-6243-F6CAD098C464}"/>
+          </ac:picMkLst>
+        </pc:picChg>
+      </pc:sldChg>
+      <pc:sldChg chg="addSp modSp new mod">
+        <pc:chgData name="Rajat Agrawal" userId="bde76780b0933dcb" providerId="LiveId" clId="{860403D2-3B03-4966-B452-B6BB53B3389A}" dt="2026-09-17T18:30:03.535" v="5" actId="1076"/>
+        <pc:sldMkLst>
+          <pc:docMk/>
+          <pc:sldMk cId="3313200389" sldId="266"/>
+        </pc:sldMkLst>
+        <pc:picChg chg="add mod">
+          <ac:chgData name="Rajat Agrawal" userId="bde76780b0933dcb" providerId="LiveId" clId="{860403D2-3B03-4966-B452-B6BB53B3389A}" dt="2026-09-17T18:30:03.535" v="5" actId="1076"/>
+          <ac:picMkLst>
+            <pc:docMk/>
+            <pc:sldMk cId="3313200389" sldId="266"/>
+            <ac:picMk id="3" creationId="{0BF43B2B-D2D8-57AA-5211-EE13260897FB}"/>
+          </ac:picMkLst>
+        </pc:picChg>
+      </pc:sldChg>
+      <pc:sldChg chg="addSp modSp new mod">
+        <pc:chgData name="Rajat Agrawal" userId="bde76780b0933dcb" providerId="LiveId" clId="{860403D2-3B03-4966-B452-B6BB53B3389A}" dt="2026-09-17T19:15:55.845" v="9" actId="14100"/>
+        <pc:sldMkLst>
+          <pc:docMk/>
+          <pc:sldMk cId="3227307961" sldId="267"/>
+        </pc:sldMkLst>
+        <pc:picChg chg="add mod">
+          <ac:chgData name="Rajat Agrawal" userId="bde76780b0933dcb" providerId="LiveId" clId="{860403D2-3B03-4966-B452-B6BB53B3389A}" dt="2026-09-17T19:15:55.845" v="9" actId="14100"/>
+          <ac:picMkLst>
+            <pc:docMk/>
+            <pc:sldMk cId="3227307961" sldId="267"/>
+            <ac:picMk id="3" creationId="{F7EE3E4E-1631-BFE3-0F52-3B0963176886}"/>
+          </ac:picMkLst>
+        </pc:picChg>
+      </pc:sldChg>
+      <pc:sldChg chg="addSp modSp new mod">
+        <pc:chgData name="Rajat Agrawal" userId="bde76780b0933dcb" providerId="LiveId" clId="{860403D2-3B03-4966-B452-B6BB53B3389A}" dt="2026-09-17T19:18:01.442" v="12" actId="14100"/>
+        <pc:sldMkLst>
+          <pc:docMk/>
+          <pc:sldMk cId="2519748986" sldId="268"/>
+        </pc:sldMkLst>
+        <pc:picChg chg="add mod">
+          <ac:chgData name="Rajat Agrawal" userId="bde76780b0933dcb" providerId="LiveId" clId="{860403D2-3B03-4966-B452-B6BB53B3389A}" dt="2026-09-17T19:18:01.442" v="12" actId="14100"/>
+          <ac:picMkLst>
+            <pc:docMk/>
+            <pc:sldMk cId="2519748986" sldId="268"/>
+            <ac:picMk id="3" creationId="{46FDA4BD-67DC-7840-9831-7289F6B38392}"/>
+          </ac:picMkLst>
+        </pc:picChg>
+      </pc:sldChg>
+      <pc:sldChg chg="addSp new mod">
+        <pc:chgData name="Rajat Agrawal" userId="bde76780b0933dcb" providerId="LiveId" clId="{860403D2-3B03-4966-B452-B6BB53B3389A}" dt="2026-09-17T19:24:26.676" v="14" actId="22"/>
+        <pc:sldMkLst>
+          <pc:docMk/>
+          <pc:sldMk cId="2676518201" sldId="269"/>
+        </pc:sldMkLst>
+        <pc:picChg chg="add">
+          <ac:chgData name="Rajat Agrawal" userId="bde76780b0933dcb" providerId="LiveId" clId="{860403D2-3B03-4966-B452-B6BB53B3389A}" dt="2026-09-17T19:24:26.676" v="14" actId="22"/>
+          <ac:picMkLst>
+            <pc:docMk/>
+            <pc:sldMk cId="2676518201" sldId="269"/>
+            <ac:picMk id="3" creationId="{D49C19D2-6E63-6CED-3D5D-52B37D71B6BC}"/>
+          </ac:picMkLst>
+        </pc:picChg>
+      </pc:sldChg>
+      <pc:sldChg chg="addSp new mod">
+        <pc:chgData name="Rajat Agrawal" userId="bde76780b0933dcb" providerId="LiveId" clId="{860403D2-3B03-4966-B452-B6BB53B3389A}" dt="2026-09-17T19:43:21.215" v="16" actId="22"/>
+        <pc:sldMkLst>
+          <pc:docMk/>
+          <pc:sldMk cId="3723801732" sldId="270"/>
+        </pc:sldMkLst>
+        <pc:picChg chg="add">
+          <ac:chgData name="Rajat Agrawal" userId="bde76780b0933dcb" providerId="LiveId" clId="{860403D2-3B03-4966-B452-B6BB53B3389A}" dt="2026-09-17T19:43:21.215" v="16" actId="22"/>
+          <ac:picMkLst>
+            <pc:docMk/>
+            <pc:sldMk cId="3723801732" sldId="270"/>
+            <ac:picMk id="3" creationId="{569E7508-5421-C8C6-3C7B-0B3156FDD317}"/>
+          </ac:picMkLst>
+        </pc:picChg>
+      </pc:sldChg>
+      <pc:sldChg chg="addSp new mod">
+        <pc:chgData name="Rajat Agrawal" userId="bde76780b0933dcb" providerId="LiveId" clId="{860403D2-3B03-4966-B452-B6BB53B3389A}" dt="2026-09-17T19:43:41.835" v="18" actId="22"/>
+        <pc:sldMkLst>
+          <pc:docMk/>
+          <pc:sldMk cId="2852547919" sldId="271"/>
+        </pc:sldMkLst>
+        <pc:picChg chg="add">
+          <ac:chgData name="Rajat Agrawal" userId="bde76780b0933dcb" providerId="LiveId" clId="{860403D2-3B03-4966-B452-B6BB53B3389A}" dt="2026-09-17T19:43:41.835" v="18" actId="22"/>
+          <ac:picMkLst>
+            <pc:docMk/>
+            <pc:sldMk cId="2852547919" sldId="271"/>
+            <ac:picMk id="3" creationId="{852B2813-EE27-C7D8-1071-592EE8D61935}"/>
+          </ac:picMkLst>
+        </pc:picChg>
+      </pc:sldChg>
+      <pc:sldChg chg="addSp modSp new mod">
+        <pc:chgData name="Rajat Agrawal" userId="bde76780b0933dcb" providerId="LiveId" clId="{860403D2-3B03-4966-B452-B6BB53B3389A}" dt="2026-09-17T19:44:17.664" v="22" actId="14100"/>
+        <pc:sldMkLst>
+          <pc:docMk/>
+          <pc:sldMk cId="2012699970" sldId="272"/>
+        </pc:sldMkLst>
+        <pc:picChg chg="add mod">
+          <ac:chgData name="Rajat Agrawal" userId="bde76780b0933dcb" providerId="LiveId" clId="{860403D2-3B03-4966-B452-B6BB53B3389A}" dt="2026-09-17T19:44:17.664" v="22" actId="14100"/>
+          <ac:picMkLst>
+            <pc:docMk/>
+            <pc:sldMk cId="2012699970" sldId="272"/>
+            <ac:picMk id="3" creationId="{B8B84788-81D7-1C0C-387F-7D2EAB096A67}"/>
+          </ac:picMkLst>
+        </pc:picChg>
+      </pc:sldChg>
+    </pc:docChg>
+  </pc:docChgLst>
+</pc:chgInfo>
 </file>
 
 <file path=ppt/slideLayouts/slideLayout1.xml><?xml version="1.0" encoding="utf-8"?>
@@ -3404,6 +3546,486 @@
     <p:extLst>
       <p:ext uri="{BB962C8B-B14F-4D97-AF65-F5344CB8AC3E}">
         <p14:creationId xmlns:p14="http://schemas.microsoft.com/office/powerpoint/2010/main" val="516121202"/>
+      </p:ext>
+    </p:extLst>
+  </p:cSld>
+  <p:clrMapOvr>
+    <a:masterClrMapping/>
+  </p:clrMapOvr>
+</p:sld>
+</file>
+
+<file path=ppt/slides/slide10.xml><?xml version="1.0" encoding="utf-8"?>
+<p:sld xmlns:a="http://schemas.openxmlformats.org/drawingml/2006/main" xmlns:r="http://schemas.openxmlformats.org/officeDocument/2006/relationships" xmlns:p="http://schemas.openxmlformats.org/presentationml/2006/main">
+  <p:cSld>
+    <p:spTree>
+      <p:nvGrpSpPr>
+        <p:cNvPr id="1" name=""/>
+        <p:cNvGrpSpPr/>
+        <p:nvPr/>
+      </p:nvGrpSpPr>
+      <p:grpSpPr>
+        <a:xfrm>
+          <a:off x="0" y="0"/>
+          <a:ext cx="0" cy="0"/>
+          <a:chOff x="0" y="0"/>
+          <a:chExt cx="0" cy="0"/>
+        </a:xfrm>
+      </p:grpSpPr>
+      <p:pic>
+        <p:nvPicPr>
+          <p:cNvPr id="3" name="Picture 2">
+            <a:extLst>
+              <a:ext uri="{FF2B5EF4-FFF2-40B4-BE49-F238E27FC236}">
+                <a16:creationId xmlns:a16="http://schemas.microsoft.com/office/drawing/2014/main" id="{6AB7A7AA-B285-E7DE-6243-F6CAD098C464}"/>
+              </a:ext>
+            </a:extLst>
+          </p:cNvPr>
+          <p:cNvPicPr>
+            <a:picLocks noChangeAspect="1"/>
+          </p:cNvPicPr>
+          <p:nvPr/>
+        </p:nvPicPr>
+        <p:blipFill>
+          <a:blip r:embed="rId2"/>
+          <a:stretch>
+            <a:fillRect/>
+          </a:stretch>
+        </p:blipFill>
+        <p:spPr>
+          <a:xfrm>
+            <a:off x="1687448" y="1135181"/>
+            <a:ext cx="8817104" cy="4587638"/>
+          </a:xfrm>
+          <a:prstGeom prst="rect">
+            <a:avLst/>
+          </a:prstGeom>
+        </p:spPr>
+      </p:pic>
+    </p:spTree>
+    <p:extLst>
+      <p:ext uri="{BB962C8B-B14F-4D97-AF65-F5344CB8AC3E}">
+        <p14:creationId xmlns:p14="http://schemas.microsoft.com/office/powerpoint/2010/main" val="459814618"/>
+      </p:ext>
+    </p:extLst>
+  </p:cSld>
+  <p:clrMapOvr>
+    <a:masterClrMapping/>
+  </p:clrMapOvr>
+</p:sld>
+</file>
+
+<file path=ppt/slides/slide11.xml><?xml version="1.0" encoding="utf-8"?>
+<p:sld xmlns:a="http://schemas.openxmlformats.org/drawingml/2006/main" xmlns:r="http://schemas.openxmlformats.org/officeDocument/2006/relationships" xmlns:p="http://schemas.openxmlformats.org/presentationml/2006/main">
+  <p:cSld>
+    <p:spTree>
+      <p:nvGrpSpPr>
+        <p:cNvPr id="1" name=""/>
+        <p:cNvGrpSpPr/>
+        <p:nvPr/>
+      </p:nvGrpSpPr>
+      <p:grpSpPr>
+        <a:xfrm>
+          <a:off x="0" y="0"/>
+          <a:ext cx="0" cy="0"/>
+          <a:chOff x="0" y="0"/>
+          <a:chExt cx="0" cy="0"/>
+        </a:xfrm>
+      </p:grpSpPr>
+      <p:pic>
+        <p:nvPicPr>
+          <p:cNvPr id="3" name="Picture 2">
+            <a:extLst>
+              <a:ext uri="{FF2B5EF4-FFF2-40B4-BE49-F238E27FC236}">
+                <a16:creationId xmlns:a16="http://schemas.microsoft.com/office/drawing/2014/main" id="{0BF43B2B-D2D8-57AA-5211-EE13260897FB}"/>
+              </a:ext>
+            </a:extLst>
+          </p:cNvPr>
+          <p:cNvPicPr>
+            <a:picLocks noChangeAspect="1"/>
+          </p:cNvPicPr>
+          <p:nvPr/>
+        </p:nvPicPr>
+        <p:blipFill>
+          <a:blip r:embed="rId2"/>
+          <a:stretch>
+            <a:fillRect/>
+          </a:stretch>
+        </p:blipFill>
+        <p:spPr>
+          <a:xfrm>
+            <a:off x="1300768" y="1034697"/>
+            <a:ext cx="10891232" cy="5546973"/>
+          </a:xfrm>
+          <a:prstGeom prst="rect">
+            <a:avLst/>
+          </a:prstGeom>
+        </p:spPr>
+      </p:pic>
+    </p:spTree>
+    <p:extLst>
+      <p:ext uri="{BB962C8B-B14F-4D97-AF65-F5344CB8AC3E}">
+        <p14:creationId xmlns:p14="http://schemas.microsoft.com/office/powerpoint/2010/main" val="3313200389"/>
+      </p:ext>
+    </p:extLst>
+  </p:cSld>
+  <p:clrMapOvr>
+    <a:masterClrMapping/>
+  </p:clrMapOvr>
+</p:sld>
+</file>
+
+<file path=ppt/slides/slide12.xml><?xml version="1.0" encoding="utf-8"?>
+<p:sld xmlns:a="http://schemas.openxmlformats.org/drawingml/2006/main" xmlns:r="http://schemas.openxmlformats.org/officeDocument/2006/relationships" xmlns:p="http://schemas.openxmlformats.org/presentationml/2006/main">
+  <p:cSld>
+    <p:spTree>
+      <p:nvGrpSpPr>
+        <p:cNvPr id="1" name=""/>
+        <p:cNvGrpSpPr/>
+        <p:nvPr/>
+      </p:nvGrpSpPr>
+      <p:grpSpPr>
+        <a:xfrm>
+          <a:off x="0" y="0"/>
+          <a:ext cx="0" cy="0"/>
+          <a:chOff x="0" y="0"/>
+          <a:chExt cx="0" cy="0"/>
+        </a:xfrm>
+      </p:grpSpPr>
+      <p:pic>
+        <p:nvPicPr>
+          <p:cNvPr id="3" name="Picture 2">
+            <a:extLst>
+              <a:ext uri="{FF2B5EF4-FFF2-40B4-BE49-F238E27FC236}">
+                <a16:creationId xmlns:a16="http://schemas.microsoft.com/office/drawing/2014/main" id="{F7EE3E4E-1631-BFE3-0F52-3B0963176886}"/>
+              </a:ext>
+            </a:extLst>
+          </p:cNvPr>
+          <p:cNvPicPr>
+            <a:picLocks noChangeAspect="1"/>
+          </p:cNvPicPr>
+          <p:nvPr/>
+        </p:nvPicPr>
+        <p:blipFill>
+          <a:blip r:embed="rId2"/>
+          <a:stretch>
+            <a:fillRect/>
+          </a:stretch>
+        </p:blipFill>
+        <p:spPr>
+          <a:xfrm>
+            <a:off x="1045029" y="714323"/>
+            <a:ext cx="10355998" cy="5565897"/>
+          </a:xfrm>
+          <a:prstGeom prst="rect">
+            <a:avLst/>
+          </a:prstGeom>
+        </p:spPr>
+      </p:pic>
+    </p:spTree>
+    <p:extLst>
+      <p:ext uri="{BB962C8B-B14F-4D97-AF65-F5344CB8AC3E}">
+        <p14:creationId xmlns:p14="http://schemas.microsoft.com/office/powerpoint/2010/main" val="3227307961"/>
+      </p:ext>
+    </p:extLst>
+  </p:cSld>
+  <p:clrMapOvr>
+    <a:masterClrMapping/>
+  </p:clrMapOvr>
+</p:sld>
+</file>
+
+<file path=ppt/slides/slide13.xml><?xml version="1.0" encoding="utf-8"?>
+<p:sld xmlns:a="http://schemas.openxmlformats.org/drawingml/2006/main" xmlns:r="http://schemas.openxmlformats.org/officeDocument/2006/relationships" xmlns:p="http://schemas.openxmlformats.org/presentationml/2006/main">
+  <p:cSld>
+    <p:spTree>
+      <p:nvGrpSpPr>
+        <p:cNvPr id="1" name=""/>
+        <p:cNvGrpSpPr/>
+        <p:nvPr/>
+      </p:nvGrpSpPr>
+      <p:grpSpPr>
+        <a:xfrm>
+          <a:off x="0" y="0"/>
+          <a:ext cx="0" cy="0"/>
+          <a:chOff x="0" y="0"/>
+          <a:chExt cx="0" cy="0"/>
+        </a:xfrm>
+      </p:grpSpPr>
+      <p:pic>
+        <p:nvPicPr>
+          <p:cNvPr id="3" name="Picture 2">
+            <a:extLst>
+              <a:ext uri="{FF2B5EF4-FFF2-40B4-BE49-F238E27FC236}">
+                <a16:creationId xmlns:a16="http://schemas.microsoft.com/office/drawing/2014/main" id="{46FDA4BD-67DC-7840-9831-7289F6B38392}"/>
+              </a:ext>
+            </a:extLst>
+          </p:cNvPr>
+          <p:cNvPicPr>
+            <a:picLocks noChangeAspect="1"/>
+          </p:cNvPicPr>
+          <p:nvPr/>
+        </p:nvPicPr>
+        <p:blipFill>
+          <a:blip r:embed="rId2"/>
+          <a:stretch>
+            <a:fillRect/>
+          </a:stretch>
+        </p:blipFill>
+        <p:spPr>
+          <a:xfrm>
+            <a:off x="1695068" y="1078026"/>
+            <a:ext cx="9663064" cy="5162000"/>
+          </a:xfrm>
+          <a:prstGeom prst="rect">
+            <a:avLst/>
+          </a:prstGeom>
+        </p:spPr>
+      </p:pic>
+    </p:spTree>
+    <p:extLst>
+      <p:ext uri="{BB962C8B-B14F-4D97-AF65-F5344CB8AC3E}">
+        <p14:creationId xmlns:p14="http://schemas.microsoft.com/office/powerpoint/2010/main" val="2519748986"/>
+      </p:ext>
+    </p:extLst>
+  </p:cSld>
+  <p:clrMapOvr>
+    <a:masterClrMapping/>
+  </p:clrMapOvr>
+</p:sld>
+</file>
+
+<file path=ppt/slides/slide14.xml><?xml version="1.0" encoding="utf-8"?>
+<p:sld xmlns:a="http://schemas.openxmlformats.org/drawingml/2006/main" xmlns:r="http://schemas.openxmlformats.org/officeDocument/2006/relationships" xmlns:p="http://schemas.openxmlformats.org/presentationml/2006/main">
+  <p:cSld>
+    <p:spTree>
+      <p:nvGrpSpPr>
+        <p:cNvPr id="1" name=""/>
+        <p:cNvGrpSpPr/>
+        <p:nvPr/>
+      </p:nvGrpSpPr>
+      <p:grpSpPr>
+        <a:xfrm>
+          <a:off x="0" y="0"/>
+          <a:ext cx="0" cy="0"/>
+          <a:chOff x="0" y="0"/>
+          <a:chExt cx="0" cy="0"/>
+        </a:xfrm>
+      </p:grpSpPr>
+      <p:pic>
+        <p:nvPicPr>
+          <p:cNvPr id="3" name="Picture 2">
+            <a:extLst>
+              <a:ext uri="{FF2B5EF4-FFF2-40B4-BE49-F238E27FC236}">
+                <a16:creationId xmlns:a16="http://schemas.microsoft.com/office/drawing/2014/main" id="{D49C19D2-6E63-6CED-3D5D-52B37D71B6BC}"/>
+              </a:ext>
+            </a:extLst>
+          </p:cNvPr>
+          <p:cNvPicPr>
+            <a:picLocks noChangeAspect="1"/>
+          </p:cNvPicPr>
+          <p:nvPr/>
+        </p:nvPicPr>
+        <p:blipFill>
+          <a:blip r:embed="rId2"/>
+          <a:stretch>
+            <a:fillRect/>
+          </a:stretch>
+        </p:blipFill>
+        <p:spPr>
+          <a:xfrm>
+            <a:off x="1592189" y="1112319"/>
+            <a:ext cx="9007621" cy="4633362"/>
+          </a:xfrm>
+          <a:prstGeom prst="rect">
+            <a:avLst/>
+          </a:prstGeom>
+        </p:spPr>
+      </p:pic>
+    </p:spTree>
+    <p:extLst>
+      <p:ext uri="{BB962C8B-B14F-4D97-AF65-F5344CB8AC3E}">
+        <p14:creationId xmlns:p14="http://schemas.microsoft.com/office/powerpoint/2010/main" val="2676518201"/>
+      </p:ext>
+    </p:extLst>
+  </p:cSld>
+  <p:clrMapOvr>
+    <a:masterClrMapping/>
+  </p:clrMapOvr>
+</p:sld>
+</file>
+
+<file path=ppt/slides/slide15.xml><?xml version="1.0" encoding="utf-8"?>
+<p:sld xmlns:a="http://schemas.openxmlformats.org/drawingml/2006/main" xmlns:r="http://schemas.openxmlformats.org/officeDocument/2006/relationships" xmlns:p="http://schemas.openxmlformats.org/presentationml/2006/main">
+  <p:cSld>
+    <p:spTree>
+      <p:nvGrpSpPr>
+        <p:cNvPr id="1" name=""/>
+        <p:cNvGrpSpPr/>
+        <p:nvPr/>
+      </p:nvGrpSpPr>
+      <p:grpSpPr>
+        <a:xfrm>
+          <a:off x="0" y="0"/>
+          <a:ext cx="0" cy="0"/>
+          <a:chOff x="0" y="0"/>
+          <a:chExt cx="0" cy="0"/>
+        </a:xfrm>
+      </p:grpSpPr>
+      <p:pic>
+        <p:nvPicPr>
+          <p:cNvPr id="3" name="Picture 2">
+            <a:extLst>
+              <a:ext uri="{FF2B5EF4-FFF2-40B4-BE49-F238E27FC236}">
+                <a16:creationId xmlns:a16="http://schemas.microsoft.com/office/drawing/2014/main" id="{569E7508-5421-C8C6-3C7B-0B3156FDD317}"/>
+              </a:ext>
+            </a:extLst>
+          </p:cNvPr>
+          <p:cNvPicPr>
+            <a:picLocks noChangeAspect="1"/>
+          </p:cNvPicPr>
+          <p:nvPr/>
+        </p:nvPicPr>
+        <p:blipFill>
+          <a:blip r:embed="rId2"/>
+          <a:stretch>
+            <a:fillRect/>
+          </a:stretch>
+        </p:blipFill>
+        <p:spPr>
+          <a:xfrm>
+            <a:off x="2140877" y="1249491"/>
+            <a:ext cx="7910245" cy="4359018"/>
+          </a:xfrm>
+          <a:prstGeom prst="rect">
+            <a:avLst/>
+          </a:prstGeom>
+        </p:spPr>
+      </p:pic>
+    </p:spTree>
+    <p:extLst>
+      <p:ext uri="{BB962C8B-B14F-4D97-AF65-F5344CB8AC3E}">
+        <p14:creationId xmlns:p14="http://schemas.microsoft.com/office/powerpoint/2010/main" val="3723801732"/>
+      </p:ext>
+    </p:extLst>
+  </p:cSld>
+  <p:clrMapOvr>
+    <a:masterClrMapping/>
+  </p:clrMapOvr>
+</p:sld>
+</file>
+
+<file path=ppt/slides/slide16.xml><?xml version="1.0" encoding="utf-8"?>
+<p:sld xmlns:a="http://schemas.openxmlformats.org/drawingml/2006/main" xmlns:r="http://schemas.openxmlformats.org/officeDocument/2006/relationships" xmlns:p="http://schemas.openxmlformats.org/presentationml/2006/main">
+  <p:cSld>
+    <p:spTree>
+      <p:nvGrpSpPr>
+        <p:cNvPr id="1" name=""/>
+        <p:cNvGrpSpPr/>
+        <p:nvPr/>
+      </p:nvGrpSpPr>
+      <p:grpSpPr>
+        <a:xfrm>
+          <a:off x="0" y="0"/>
+          <a:ext cx="0" cy="0"/>
+          <a:chOff x="0" y="0"/>
+          <a:chExt cx="0" cy="0"/>
+        </a:xfrm>
+      </p:grpSpPr>
+      <p:pic>
+        <p:nvPicPr>
+          <p:cNvPr id="3" name="Picture 2">
+            <a:extLst>
+              <a:ext uri="{FF2B5EF4-FFF2-40B4-BE49-F238E27FC236}">
+                <a16:creationId xmlns:a16="http://schemas.microsoft.com/office/drawing/2014/main" id="{852B2813-EE27-C7D8-1071-592EE8D61935}"/>
+              </a:ext>
+            </a:extLst>
+          </p:cNvPr>
+          <p:cNvPicPr>
+            <a:picLocks noChangeAspect="1"/>
+          </p:cNvPicPr>
+          <p:nvPr/>
+        </p:nvPicPr>
+        <p:blipFill>
+          <a:blip r:embed="rId2"/>
+          <a:stretch>
+            <a:fillRect/>
+          </a:stretch>
+        </p:blipFill>
+        <p:spPr>
+          <a:xfrm>
+            <a:off x="1645534" y="1161853"/>
+            <a:ext cx="8900931" cy="4534293"/>
+          </a:xfrm>
+          <a:prstGeom prst="rect">
+            <a:avLst/>
+          </a:prstGeom>
+        </p:spPr>
+      </p:pic>
+    </p:spTree>
+    <p:extLst>
+      <p:ext uri="{BB962C8B-B14F-4D97-AF65-F5344CB8AC3E}">
+        <p14:creationId xmlns:p14="http://schemas.microsoft.com/office/powerpoint/2010/main" val="2852547919"/>
+      </p:ext>
+    </p:extLst>
+  </p:cSld>
+  <p:clrMapOvr>
+    <a:masterClrMapping/>
+  </p:clrMapOvr>
+</p:sld>
+</file>
+
+<file path=ppt/slides/slide17.xml><?xml version="1.0" encoding="utf-8"?>
+<p:sld xmlns:a="http://schemas.openxmlformats.org/drawingml/2006/main" xmlns:r="http://schemas.openxmlformats.org/officeDocument/2006/relationships" xmlns:p="http://schemas.openxmlformats.org/presentationml/2006/main">
+  <p:cSld>
+    <p:spTree>
+      <p:nvGrpSpPr>
+        <p:cNvPr id="1" name=""/>
+        <p:cNvGrpSpPr/>
+        <p:nvPr/>
+      </p:nvGrpSpPr>
+      <p:grpSpPr>
+        <a:xfrm>
+          <a:off x="0" y="0"/>
+          <a:ext cx="0" cy="0"/>
+          <a:chOff x="0" y="0"/>
+          <a:chExt cx="0" cy="0"/>
+        </a:xfrm>
+      </p:grpSpPr>
+      <p:pic>
+        <p:nvPicPr>
+          <p:cNvPr id="3" name="Picture 2">
+            <a:extLst>
+              <a:ext uri="{FF2B5EF4-FFF2-40B4-BE49-F238E27FC236}">
+                <a16:creationId xmlns:a16="http://schemas.microsoft.com/office/drawing/2014/main" id="{B8B84788-81D7-1C0C-387F-7D2EAB096A67}"/>
+              </a:ext>
+            </a:extLst>
+          </p:cNvPr>
+          <p:cNvPicPr>
+            <a:picLocks noChangeAspect="1"/>
+          </p:cNvPicPr>
+          <p:nvPr/>
+        </p:nvPicPr>
+        <p:blipFill>
+          <a:blip r:embed="rId2"/>
+          <a:stretch>
+            <a:fillRect/>
+          </a:stretch>
+        </p:blipFill>
+        <p:spPr>
+          <a:xfrm>
+            <a:off x="1949381" y="582683"/>
+            <a:ext cx="9023420" cy="5692633"/>
+          </a:xfrm>
+          <a:prstGeom prst="rect">
+            <a:avLst/>
+          </a:prstGeom>
+        </p:spPr>
+      </p:pic>
+    </p:spTree>
+    <p:extLst>
+      <p:ext uri="{BB962C8B-B14F-4D97-AF65-F5344CB8AC3E}">
+        <p14:creationId xmlns:p14="http://schemas.microsoft.com/office/powerpoint/2010/main" val="2012699970"/>
       </p:ext>
     </p:extLst>
   </p:cSld>

</xml_diff>